<commit_message>
Update 2026 risk summary slides with the new requirements matrix
19 visits (7 internal, 4 external, 8 SSF); refreshed repeated topics,
monthly calendar and most-audited norms.

Co-Authored-By: Claude Opus 5.5 <noreply@anthropic.com>
Claude-Session: https://claude.ai/code/session_01QC1XfLyMdcgUULyFVZxtv6
</commit_message>
<xml_diff>
--- a/presentacion-lunes/Resumen_Riesgos_2026_Opcion_A.pptx
+++ b/presentacion-lunes/Resumen_Riesgos_2026_Opcion_A.pptx
@@ -251,16 +251,16 @@
                   <c:v>0</c:v>
                 </c:pt>
                 <c:pt idx="2">
-                  <c:v>0</c:v>
+                  <c:v>1</c:v>
                 </c:pt>
                 <c:pt idx="3">
                   <c:v>0</c:v>
                 </c:pt>
                 <c:pt idx="4">
-                  <c:v>1</c:v>
+                  <c:v>2</c:v>
                 </c:pt>
                 <c:pt idx="5">
-                  <c:v>0</c:v>
+                  <c:v>2</c:v>
                 </c:pt>
                 <c:pt idx="6">
                   <c:v>0</c:v>
@@ -354,7 +354,7 @@
                 <c:formatCode>General</c:formatCode>
                 <c:ptCount val="12"/>
                 <c:pt idx="0">
-                  <c:v>0</c:v>
+                  <c:v>1</c:v>
                 </c:pt>
                 <c:pt idx="1">
                   <c:v>0</c:v>
@@ -363,7 +363,7 @@
                   <c:v>0</c:v>
                 </c:pt>
                 <c:pt idx="3">
-                  <c:v>0</c:v>
+                  <c:v>1</c:v>
                 </c:pt>
                 <c:pt idx="4">
                   <c:v>0</c:v>
@@ -372,7 +372,7 @@
                   <c:v>0</c:v>
                 </c:pt>
                 <c:pt idx="6">
-                  <c:v>0</c:v>
+                  <c:v>1</c:v>
                 </c:pt>
                 <c:pt idx="7">
                   <c:v>0</c:v>
@@ -1038,7 +1038,7 @@
           <a:lstStyle/>
           <a:p>
             <a:r>
-              <a:t>Resumen de lo que nos pidieron en 2026. Vinieron 12 veces: 3 auditorías internas, 1 externa y 8 visitas de la SSF. Seis temas los pidieron 2 o más entidades: hay que tenerlos siempre listos, sobre todo las Actas del Comité de Riesgos (NRP-20), que se pidieron 4 veces. NRP-20 es la norma más revisada (5 veces, 3 entidades). Octubre fue el mes de mayor carga: coincidieron Interna, Externa y SSF.</a:t>
+              <a:t>Resumen de lo que nos pidieron en 2026. Vinieron 19 veces: 7 auditorías internas, 4 externas y 8 visitas de la SSF. Seis temas los pidieron 2 o más entidades: hay que tenerlos siempre listos, sobre todo las Actas del Comité de Riesgos (NRP-20), pedidas 4 veces, y Clasificación de cartera y el Plan de Continuidad, pedidos 3 veces cada uno. NRP-20 es la norma más revisada (5 veces, 3 entidades). En octubre coincidieron Interna, Externa y SSF.</a:t>
             </a:r>
           </a:p>
         </p:txBody>
@@ -4664,7 +4664,7 @@
                 </a:solidFill>
                 <a:latin typeface="Century Gothic"/>
               </a:rPr>
-              <a:t>12</a:t>
+              <a:t>19</a:t>
             </a:r>
           </a:p>
         </p:txBody>
@@ -4734,7 +4734,7 @@
                 </a:solidFill>
                 <a:latin typeface="Arial"/>
               </a:rPr>
-              <a:t>3 Interna · 1 Externa · 8 SSF</a:t>
+              <a:t>7 Interna · 4 Externa · 8 SSF</a:t>
             </a:r>
           </a:p>
         </p:txBody>
@@ -4883,7 +4883,7 @@
                 </a:solidFill>
                 <a:latin typeface="Century Gothic"/>
               </a:rPr>
-              <a:t>24</a:t>
+              <a:t>26</a:t>
             </a:r>
           </a:p>
         </p:txBody>
@@ -4953,7 +4953,7 @@
                 </a:solidFill>
                 <a:latin typeface="Arial"/>
               </a:rPr>
-              <a:t>de 29 temas del catálogo</a:t>
+              <a:t>de 31 temas del catálogo</a:t>
             </a:r>
           </a:p>
         </p:txBody>
@@ -6027,7 +6027,7 @@
                 </a:solidFill>
                 <a:latin typeface="Arial"/>
               </a:rPr>
-              <a:t>Pérdida Esperada</a:t>
+              <a:t>Clasificación de cartera, mora y reservas</a:t>
             </a:r>
           </a:p>
         </p:txBody>
@@ -6076,7 +6076,7 @@
         <p:spPr>
           <a:xfrm>
             <a:off x="9738359" y="4425696"/>
-            <a:ext cx="566928" cy="237744"/>
+            <a:ext cx="731520" cy="237744"/>
           </a:xfrm>
           <a:prstGeom prst="roundRect">
             <a:avLst>
@@ -6117,7 +6117,7 @@
                 </a:solidFill>
                 <a:latin typeface="Arial"/>
               </a:rPr>
-              <a:t>Interna</a:t>
+              <a:t>Interna ×2</a:t>
             </a:r>
           </a:p>
         </p:txBody>
@@ -6130,7 +6130,7 @@
         </p:nvSpPr>
         <p:spPr>
           <a:xfrm>
-            <a:off x="10378439" y="4425696"/>
+            <a:off x="10543032" y="4425696"/>
             <a:ext cx="566928" cy="237744"/>
           </a:xfrm>
           <a:prstGeom prst="roundRect">
@@ -6253,7 +6253,7 @@
                 </a:solidFill>
                 <a:latin typeface="Arial"/>
               </a:rPr>
-              <a:t>Clasificación de cartera, mora y reservas</a:t>
+              <a:t>Plan de Continuidad (BCP/DRP)</a:t>
             </a:r>
           </a:p>
         </p:txBody>
@@ -6288,7 +6288,7 @@
                 </a:solidFill>
                 <a:latin typeface="Arial"/>
               </a:rPr>
-              <a:t>NCB-022</a:t>
+              <a:t>NRP-24</a:t>
             </a:r>
           </a:p>
         </p:txBody>
@@ -6302,7 +6302,7 @@
         <p:spPr>
           <a:xfrm>
             <a:off x="9738359" y="4809744"/>
-            <a:ext cx="566928" cy="237744"/>
+            <a:ext cx="731520" cy="237744"/>
           </a:xfrm>
           <a:prstGeom prst="roundRect">
             <a:avLst>
@@ -6343,7 +6343,7 @@
                 </a:solidFill>
                 <a:latin typeface="Arial"/>
               </a:rPr>
-              <a:t>Interna</a:t>
+              <a:t>Interna ×2</a:t>
             </a:r>
           </a:p>
         </p:txBody>
@@ -6356,7 +6356,7 @@
         </p:nvSpPr>
         <p:spPr>
           <a:xfrm>
-            <a:off x="10378439" y="4809744"/>
+            <a:off x="10543032" y="4809744"/>
             <a:ext cx="566928" cy="237744"/>
           </a:xfrm>
           <a:prstGeom prst="roundRect">
@@ -6433,7 +6433,7 @@
                 </a:solidFill>
                 <a:latin typeface="Arial"/>
               </a:rPr>
-              <a:t>Remisiones a SSF / central de riesgos</a:t>
+              <a:t>Pérdida Esperada</a:t>
             </a:r>
           </a:p>
         </p:txBody>
@@ -6659,7 +6659,7 @@
                 </a:solidFill>
                 <a:latin typeface="Arial"/>
               </a:rPr>
-              <a:t>Gobierno Corporativo</a:t>
+              <a:t>Remisiones a SSF / central de riesgos</a:t>
             </a:r>
           </a:p>
         </p:txBody>
@@ -6694,7 +6694,7 @@
                 </a:solidFill>
                 <a:latin typeface="Arial"/>
               </a:rPr>
-              <a:t>NRP-17</a:t>
+              <a:t>NCB-022</a:t>
             </a:r>
           </a:p>
         </p:txBody>
@@ -6771,7 +6771,7 @@
             </a:avLst>
           </a:prstGeom>
           <a:solidFill>
-            <a:srgbClr val="2E9E5B"/>
+            <a:srgbClr val="E8871E"/>
           </a:solidFill>
           <a:ln>
             <a:noFill/>
@@ -6804,7 +6804,7 @@
                 </a:solidFill>
                 <a:latin typeface="Arial"/>
               </a:rPr>
-              <a:t>SSF</a:t>
+              <a:t>Externa</a:t>
             </a:r>
           </a:p>
         </p:txBody>
@@ -6839,7 +6839,7 @@
                 </a:solidFill>
                 <a:latin typeface="Arial"/>
               </a:rPr>
-              <a:t>Plan de Continuidad (BCP/DRP)</a:t>
+              <a:t>Gobierno Corporativo</a:t>
             </a:r>
           </a:p>
         </p:txBody>
@@ -6874,7 +6874,7 @@
                 </a:solidFill>
                 <a:latin typeface="Arial"/>
               </a:rPr>
-              <a:t>NRP-24</a:t>
+              <a:t>NRP-17</a:t>
             </a:r>
           </a:p>
         </p:txBody>
@@ -6951,7 +6951,7 @@
             </a:avLst>
           </a:prstGeom>
           <a:solidFill>
-            <a:srgbClr val="E8871E"/>
+            <a:srgbClr val="2E9E5B"/>
           </a:solidFill>
           <a:ln>
             <a:noFill/>
@@ -6984,7 +6984,7 @@
                 </a:solidFill>
                 <a:latin typeface="Arial"/>
               </a:rPr>
-              <a:t>Externa</a:t>
+              <a:t>SSF</a:t>
             </a:r>
           </a:p>
         </p:txBody>

</xml_diff>

<commit_message>
Group the NCB-022 topics into a single repeated-topic item
Credit-risk topics (portfolio classification, expected loss, SSF
remittances) now show as one NCB-022 entry, leaving 4 repeated topics.

Co-Authored-By: Claude Opus 5.5 <noreply@anthropic.com>
Claude-Session: https://claude.ai/code/session_01QC1XfLyMdcgUULyFVZxtv6
</commit_message>
<xml_diff>
--- a/presentacion-lunes/Resumen_Riesgos_2026_Opcion_A.pptx
+++ b/presentacion-lunes/Resumen_Riesgos_2026_Opcion_A.pptx
@@ -1038,7 +1038,7 @@
           <a:lstStyle/>
           <a:p>
             <a:r>
-              <a:t>Resumen de lo que nos pidieron en 2026. Vinieron 19 veces: 7 auditorías internas, 4 externas y 8 visitas de la SSF. Seis temas los pidieron 2 o más entidades: hay que tenerlos siempre listos, sobre todo las Actas del Comité de Riesgos (NRP-20), pedidas 4 veces, y Clasificación de cartera y el Plan de Continuidad, pedidos 3 veces cada uno. NRP-20 es la norma más revisada (5 veces, 3 entidades). En octubre coincidieron Interna, Externa y SSF.</a:t>
+              <a:t>Resumen de lo que nos pidieron en 2026. Vinieron 19 veces: 7 auditorías internas, 4 externas y 8 visitas de la SSF. Cuatro temas los pidieron 2 o más entidades: hay que tenerlos siempre listos, sobre todo las Actas del Comité de Riesgos (NRP-20), pedidas 4 veces; NCB-022 (cartera, Pérdida Esperada y remisiones a SSF) y el Plan de Continuidad, 3 veces cada uno. NRP-20 es la norma más revisada (5 veces, 3 entidades). En octubre coincidieron Interna, Externa y SSF.</a:t>
             </a:r>
           </a:p>
         </p:txBody>
@@ -5102,7 +5102,7 @@
                 </a:solidFill>
                 <a:latin typeface="Century Gothic"/>
               </a:rPr>
-              <a:t>6</a:t>
+              <a:t>4</a:t>
             </a:r>
           </a:p>
         </p:txBody>
@@ -5779,12 +5779,12 @@
         </p:nvSpPr>
         <p:spPr>
           <a:xfrm>
-            <a:off x="5943600" y="3968496"/>
-            <a:ext cx="5577840" cy="384048"/>
+            <a:off x="5943600" y="4005072"/>
+            <a:ext cx="5577840" cy="548640"/>
           </a:xfrm>
           <a:prstGeom prst="roundRect">
             <a:avLst>
-              <a:gd name="adj" fmla="val 20000"/>
+              <a:gd name="adj" fmla="val 15000"/>
             </a:avLst>
           </a:prstGeom>
           <a:solidFill>
@@ -5825,8 +5825,8 @@
         </p:nvSpPr>
         <p:spPr>
           <a:xfrm>
-            <a:off x="6080759" y="4005072"/>
-            <a:ext cx="2880360" cy="310896"/>
+            <a:off x="6080759" y="4041648"/>
+            <a:ext cx="2880360" cy="475488"/>
           </a:xfrm>
           <a:prstGeom prst="rect">
             <a:avLst/>
@@ -5861,7 +5861,7 @@
         <p:spPr>
           <a:xfrm>
             <a:off x="9006840" y="4005072"/>
-            <a:ext cx="731520" cy="310896"/>
+            <a:ext cx="731520" cy="548640"/>
           </a:xfrm>
           <a:prstGeom prst="rect">
             <a:avLst/>
@@ -5876,9 +5876,9 @@
           <a:p>
             <a:pPr algn="l"/>
             <a:r>
-              <a:rPr sz="1000" b="0">
+              <a:rPr sz="1000" b="1">
                 <a:solidFill>
-                  <a:srgbClr val="5B6B7B"/>
+                  <a:srgbClr val="003D6F"/>
                 </a:solidFill>
                 <a:latin typeface="Arial"/>
               </a:rPr>
@@ -5895,7 +5895,7 @@
         </p:nvSpPr>
         <p:spPr>
           <a:xfrm>
-            <a:off x="9738359" y="4041648"/>
+            <a:off x="9738359" y="4160520"/>
             <a:ext cx="731520" cy="237744"/>
           </a:xfrm>
           <a:prstGeom prst="roundRect">
@@ -5950,7 +5950,7 @@
         </p:nvSpPr>
         <p:spPr>
           <a:xfrm>
-            <a:off x="10543032" y="4041648"/>
+            <a:off x="10543032" y="4160520"/>
             <a:ext cx="566928" cy="237744"/>
           </a:xfrm>
           <a:prstGeom prst="roundRect">
@@ -6005,8 +6005,8 @@
         </p:nvSpPr>
         <p:spPr>
           <a:xfrm>
-            <a:off x="6080759" y="4389120"/>
-            <a:ext cx="2880360" cy="310896"/>
+            <a:off x="6080759" y="4608576"/>
+            <a:ext cx="2880360" cy="475488"/>
           </a:xfrm>
           <a:prstGeom prst="rect">
             <a:avLst/>
@@ -6027,41 +6027,53 @@
                 </a:solidFill>
                 <a:latin typeface="Arial"/>
               </a:rPr>
-              <a:t>Clasificación de cartera, mora y reservas</a:t>
-            </a:r>
-          </a:p>
-        </p:txBody>
-      </p:sp>
-      <p:sp>
-        <p:nvSpPr>
-          <p:cNvPr id="49" name="TextBox 48"/>
-          <p:cNvSpPr txBox="1"/>
-          <p:nvPr/>
-        </p:nvSpPr>
-        <p:spPr>
-          <a:xfrm>
-            <a:off x="9006840" y="4389120"/>
-            <a:ext cx="731520" cy="310896"/>
-          </a:xfrm>
-          <a:prstGeom prst="rect">
-            <a:avLst/>
-          </a:prstGeom>
-          <a:noFill/>
-        </p:spPr>
-        <p:txBody>
-          <a:bodyPr wrap="square" lIns="0" rIns="0" tIns="0" bIns="0" anchor="ctr">
-            <a:spAutoFit/>
-          </a:bodyPr>
-          <a:lstStyle/>
+              <a:t>Riesgo de crédito</a:t>
+            </a:r>
+          </a:p>
           <a:p>
             <a:pPr algn="l"/>
             <a:r>
-              <a:rPr sz="1000" b="0">
+              <a:rPr sz="900" b="0">
                 <a:solidFill>
                   <a:srgbClr val="5B6B7B"/>
                 </a:solidFill>
                 <a:latin typeface="Arial"/>
               </a:rPr>
+              <a:t>Cartera, mora y reservas · Pérdida Esperada · Remisiones a SSF</a:t>
+            </a:r>
+          </a:p>
+        </p:txBody>
+      </p:sp>
+      <p:sp>
+        <p:nvSpPr>
+          <p:cNvPr id="49" name="TextBox 48"/>
+          <p:cNvSpPr txBox="1"/>
+          <p:nvPr/>
+        </p:nvSpPr>
+        <p:spPr>
+          <a:xfrm>
+            <a:off x="9006840" y="4572000"/>
+            <a:ext cx="731520" cy="548640"/>
+          </a:xfrm>
+          <a:prstGeom prst="rect">
+            <a:avLst/>
+          </a:prstGeom>
+          <a:noFill/>
+        </p:spPr>
+        <p:txBody>
+          <a:bodyPr wrap="square" lIns="0" rIns="0" tIns="0" bIns="0" anchor="ctr">
+            <a:spAutoFit/>
+          </a:bodyPr>
+          <a:lstStyle/>
+          <a:p>
+            <a:pPr algn="l"/>
+            <a:r>
+              <a:rPr sz="1000" b="1">
+                <a:solidFill>
+                  <a:srgbClr val="003D6F"/>
+                </a:solidFill>
+                <a:latin typeface="Arial"/>
+              </a:rPr>
               <a:t>NCB-022</a:t>
             </a:r>
           </a:p>
@@ -6075,7 +6087,7 @@
         </p:nvSpPr>
         <p:spPr>
           <a:xfrm>
-            <a:off x="9738359" y="4425696"/>
+            <a:off x="9738359" y="4727448"/>
             <a:ext cx="731520" cy="237744"/>
           </a:xfrm>
           <a:prstGeom prst="roundRect">
@@ -6130,7 +6142,7 @@
         </p:nvSpPr>
         <p:spPr>
           <a:xfrm>
-            <a:off x="10543032" y="4425696"/>
+            <a:off x="10543032" y="4727448"/>
             <a:ext cx="566928" cy="237744"/>
           </a:xfrm>
           <a:prstGeom prst="roundRect">
@@ -6185,12 +6197,12 @@
         </p:nvSpPr>
         <p:spPr>
           <a:xfrm>
-            <a:off x="5943600" y="4736592"/>
-            <a:ext cx="5577840" cy="384048"/>
+            <a:off x="5943600" y="5138928"/>
+            <a:ext cx="5577840" cy="548640"/>
           </a:xfrm>
           <a:prstGeom prst="roundRect">
             <a:avLst>
-              <a:gd name="adj" fmla="val 20000"/>
+              <a:gd name="adj" fmla="val 15000"/>
             </a:avLst>
           </a:prstGeom>
           <a:solidFill>
@@ -6231,8 +6243,8 @@
         </p:nvSpPr>
         <p:spPr>
           <a:xfrm>
-            <a:off x="6080759" y="4773168"/>
-            <a:ext cx="2880360" cy="310896"/>
+            <a:off x="6080759" y="5175504"/>
+            <a:ext cx="2880360" cy="475488"/>
           </a:xfrm>
           <a:prstGeom prst="rect">
             <a:avLst/>
@@ -6266,8 +6278,8 @@
         </p:nvSpPr>
         <p:spPr>
           <a:xfrm>
-            <a:off x="9006840" y="4773168"/>
-            <a:ext cx="731520" cy="310896"/>
+            <a:off x="9006840" y="5138928"/>
+            <a:ext cx="731520" cy="548640"/>
           </a:xfrm>
           <a:prstGeom prst="rect">
             <a:avLst/>
@@ -6282,9 +6294,9 @@
           <a:p>
             <a:pPr algn="l"/>
             <a:r>
-              <a:rPr sz="1000" b="0">
+              <a:rPr sz="1000" b="1">
                 <a:solidFill>
-                  <a:srgbClr val="5B6B7B"/>
+                  <a:srgbClr val="003D6F"/>
                 </a:solidFill>
                 <a:latin typeface="Arial"/>
               </a:rPr>
@@ -6301,7 +6313,7 @@
         </p:nvSpPr>
         <p:spPr>
           <a:xfrm>
-            <a:off x="9738359" y="4809744"/>
+            <a:off x="9738359" y="5294376"/>
             <a:ext cx="731520" cy="237744"/>
           </a:xfrm>
           <a:prstGeom prst="roundRect">
@@ -6356,7 +6368,7 @@
         </p:nvSpPr>
         <p:spPr>
           <a:xfrm>
-            <a:off x="10543032" y="4809744"/>
+            <a:off x="10543032" y="5294376"/>
             <a:ext cx="566928" cy="237744"/>
           </a:xfrm>
           <a:prstGeom prst="roundRect">
@@ -6411,8 +6423,8 @@
         </p:nvSpPr>
         <p:spPr>
           <a:xfrm>
-            <a:off x="6080759" y="5157216"/>
-            <a:ext cx="2880360" cy="310896"/>
+            <a:off x="6080759" y="5742432"/>
+            <a:ext cx="2880360" cy="475488"/>
           </a:xfrm>
           <a:prstGeom prst="rect">
             <a:avLst/>
@@ -6433,7 +6445,7 @@
                 </a:solidFill>
                 <a:latin typeface="Arial"/>
               </a:rPr>
-              <a:t>Pérdida Esperada</a:t>
+              <a:t>Gobierno Corporativo</a:t>
             </a:r>
           </a:p>
         </p:txBody>
@@ -6446,8 +6458,8 @@
         </p:nvSpPr>
         <p:spPr>
           <a:xfrm>
-            <a:off x="9006840" y="5157216"/>
-            <a:ext cx="731520" cy="310896"/>
+            <a:off x="9006840" y="5705856"/>
+            <a:ext cx="731520" cy="548640"/>
           </a:xfrm>
           <a:prstGeom prst="rect">
             <a:avLst/>
@@ -6462,13 +6474,13 @@
           <a:p>
             <a:pPr algn="l"/>
             <a:r>
-              <a:rPr sz="1000" b="0">
+              <a:rPr sz="1000" b="1">
                 <a:solidFill>
-                  <a:srgbClr val="5B6B7B"/>
+                  <a:srgbClr val="003D6F"/>
                 </a:solidFill>
                 <a:latin typeface="Arial"/>
               </a:rPr>
-              <a:t>NCB-022</a:t>
+              <a:t>NRP-17</a:t>
             </a:r>
           </a:p>
         </p:txBody>
@@ -6481,7 +6493,7 @@
         </p:nvSpPr>
         <p:spPr>
           <a:xfrm>
-            <a:off x="9738359" y="5193792"/>
+            <a:off x="9738359" y="5861304"/>
             <a:ext cx="566928" cy="237744"/>
           </a:xfrm>
           <a:prstGeom prst="roundRect">
@@ -6536,7 +6548,7 @@
         </p:nvSpPr>
         <p:spPr>
           <a:xfrm>
-            <a:off x="10378439" y="5193792"/>
+            <a:off x="10378439" y="5861304"/>
             <a:ext cx="566928" cy="237744"/>
           </a:xfrm>
           <a:prstGeom prst="roundRect">
@@ -6545,7 +6557,7 @@
             </a:avLst>
           </a:prstGeom>
           <a:solidFill>
-            <a:srgbClr val="E8871E"/>
+            <a:srgbClr val="2E9E5B"/>
           </a:solidFill>
           <a:ln>
             <a:noFill/>
@@ -6578,412 +6590,6 @@
                 </a:solidFill>
                 <a:latin typeface="Arial"/>
               </a:rPr>
-              <a:t>Externa</a:t>
-            </a:r>
-          </a:p>
-        </p:txBody>
-      </p:sp>
-      <p:sp>
-        <p:nvSpPr>
-          <p:cNvPr id="61" name="Rounded Rectangle 60"/>
-          <p:cNvSpPr/>
-          <p:nvPr/>
-        </p:nvSpPr>
-        <p:spPr>
-          <a:xfrm>
-            <a:off x="5943600" y="5504688"/>
-            <a:ext cx="5577840" cy="384048"/>
-          </a:xfrm>
-          <a:prstGeom prst="roundRect">
-            <a:avLst>
-              <a:gd name="adj" fmla="val 20000"/>
-            </a:avLst>
-          </a:prstGeom>
-          <a:solidFill>
-            <a:srgbClr val="EEF3F9"/>
-          </a:solidFill>
-          <a:ln>
-            <a:noFill/>
-          </a:ln>
-          <a:effectLst/>
-        </p:spPr>
-        <p:style>
-          <a:lnRef idx="1">
-            <a:schemeClr val="accent1"/>
-          </a:lnRef>
-          <a:fillRef idx="3">
-            <a:schemeClr val="accent1"/>
-          </a:fillRef>
-          <a:effectRef idx="2">
-            <a:schemeClr val="accent1"/>
-          </a:effectRef>
-          <a:fontRef idx="minor">
-            <a:schemeClr val="lt1"/>
-          </a:fontRef>
-        </p:style>
-        <p:txBody>
-          <a:bodyPr rtlCol="0" anchor="ctr"/>
-          <a:lstStyle/>
-          <a:p>
-            <a:pPr algn="ctr"/>
-          </a:p>
-        </p:txBody>
-      </p:sp>
-      <p:sp>
-        <p:nvSpPr>
-          <p:cNvPr id="62" name="TextBox 61"/>
-          <p:cNvSpPr txBox="1"/>
-          <p:nvPr/>
-        </p:nvSpPr>
-        <p:spPr>
-          <a:xfrm>
-            <a:off x="6080759" y="5541264"/>
-            <a:ext cx="2880360" cy="310896"/>
-          </a:xfrm>
-          <a:prstGeom prst="rect">
-            <a:avLst/>
-          </a:prstGeom>
-          <a:noFill/>
-        </p:spPr>
-        <p:txBody>
-          <a:bodyPr wrap="square" lIns="0" rIns="0" tIns="0" bIns="0" anchor="ctr">
-            <a:spAutoFit/>
-          </a:bodyPr>
-          <a:lstStyle/>
-          <a:p>
-            <a:pPr algn="l"/>
-            <a:r>
-              <a:rPr sz="1100" b="1">
-                <a:solidFill>
-                  <a:srgbClr val="1F2A37"/>
-                </a:solidFill>
-                <a:latin typeface="Arial"/>
-              </a:rPr>
-              <a:t>Remisiones a SSF / central de riesgos</a:t>
-            </a:r>
-          </a:p>
-        </p:txBody>
-      </p:sp>
-      <p:sp>
-        <p:nvSpPr>
-          <p:cNvPr id="63" name="TextBox 62"/>
-          <p:cNvSpPr txBox="1"/>
-          <p:nvPr/>
-        </p:nvSpPr>
-        <p:spPr>
-          <a:xfrm>
-            <a:off x="9006840" y="5541264"/>
-            <a:ext cx="731520" cy="310896"/>
-          </a:xfrm>
-          <a:prstGeom prst="rect">
-            <a:avLst/>
-          </a:prstGeom>
-          <a:noFill/>
-        </p:spPr>
-        <p:txBody>
-          <a:bodyPr wrap="square" lIns="0" rIns="0" tIns="0" bIns="0" anchor="ctr">
-            <a:spAutoFit/>
-          </a:bodyPr>
-          <a:lstStyle/>
-          <a:p>
-            <a:pPr algn="l"/>
-            <a:r>
-              <a:rPr sz="1000" b="0">
-                <a:solidFill>
-                  <a:srgbClr val="5B6B7B"/>
-                </a:solidFill>
-                <a:latin typeface="Arial"/>
-              </a:rPr>
-              <a:t>NCB-022</a:t>
-            </a:r>
-          </a:p>
-        </p:txBody>
-      </p:sp>
-      <p:sp>
-        <p:nvSpPr>
-          <p:cNvPr id="64" name="Rounded Rectangle 63"/>
-          <p:cNvSpPr/>
-          <p:nvPr/>
-        </p:nvSpPr>
-        <p:spPr>
-          <a:xfrm>
-            <a:off x="9738359" y="5577840"/>
-            <a:ext cx="566928" cy="237744"/>
-          </a:xfrm>
-          <a:prstGeom prst="roundRect">
-            <a:avLst>
-              <a:gd name="adj" fmla="val 50000"/>
-            </a:avLst>
-          </a:prstGeom>
-          <a:solidFill>
-            <a:srgbClr val="1565C0"/>
-          </a:solidFill>
-          <a:ln>
-            <a:noFill/>
-          </a:ln>
-          <a:effectLst/>
-        </p:spPr>
-        <p:style>
-          <a:lnRef idx="1">
-            <a:schemeClr val="accent1"/>
-          </a:lnRef>
-          <a:fillRef idx="3">
-            <a:schemeClr val="accent1"/>
-          </a:fillRef>
-          <a:effectRef idx="2">
-            <a:schemeClr val="accent1"/>
-          </a:effectRef>
-          <a:fontRef idx="minor">
-            <a:schemeClr val="lt1"/>
-          </a:fontRef>
-        </p:style>
-        <p:txBody>
-          <a:bodyPr rtlCol="0" anchor="ctr" lIns="0" rIns="0" tIns="0" bIns="0"/>
-          <a:lstStyle/>
-          <a:p>
-            <a:pPr algn="ctr"/>
-            <a:r>
-              <a:rPr sz="900" b="1">
-                <a:solidFill>
-                  <a:srgbClr val="FFFFFF"/>
-                </a:solidFill>
-                <a:latin typeface="Arial"/>
-              </a:rPr>
-              <a:t>Interna</a:t>
-            </a:r>
-          </a:p>
-        </p:txBody>
-      </p:sp>
-      <p:sp>
-        <p:nvSpPr>
-          <p:cNvPr id="65" name="Rounded Rectangle 64"/>
-          <p:cNvSpPr/>
-          <p:nvPr/>
-        </p:nvSpPr>
-        <p:spPr>
-          <a:xfrm>
-            <a:off x="10378439" y="5577840"/>
-            <a:ext cx="566928" cy="237744"/>
-          </a:xfrm>
-          <a:prstGeom prst="roundRect">
-            <a:avLst>
-              <a:gd name="adj" fmla="val 50000"/>
-            </a:avLst>
-          </a:prstGeom>
-          <a:solidFill>
-            <a:srgbClr val="E8871E"/>
-          </a:solidFill>
-          <a:ln>
-            <a:noFill/>
-          </a:ln>
-          <a:effectLst/>
-        </p:spPr>
-        <p:style>
-          <a:lnRef idx="1">
-            <a:schemeClr val="accent1"/>
-          </a:lnRef>
-          <a:fillRef idx="3">
-            <a:schemeClr val="accent1"/>
-          </a:fillRef>
-          <a:effectRef idx="2">
-            <a:schemeClr val="accent1"/>
-          </a:effectRef>
-          <a:fontRef idx="minor">
-            <a:schemeClr val="lt1"/>
-          </a:fontRef>
-        </p:style>
-        <p:txBody>
-          <a:bodyPr rtlCol="0" anchor="ctr" lIns="0" rIns="0" tIns="0" bIns="0"/>
-          <a:lstStyle/>
-          <a:p>
-            <a:pPr algn="ctr"/>
-            <a:r>
-              <a:rPr sz="900" b="1">
-                <a:solidFill>
-                  <a:srgbClr val="FFFFFF"/>
-                </a:solidFill>
-                <a:latin typeface="Arial"/>
-              </a:rPr>
-              <a:t>Externa</a:t>
-            </a:r>
-          </a:p>
-        </p:txBody>
-      </p:sp>
-      <p:sp>
-        <p:nvSpPr>
-          <p:cNvPr id="66" name="TextBox 65"/>
-          <p:cNvSpPr txBox="1"/>
-          <p:nvPr/>
-        </p:nvSpPr>
-        <p:spPr>
-          <a:xfrm>
-            <a:off x="6080759" y="5925312"/>
-            <a:ext cx="2880360" cy="310896"/>
-          </a:xfrm>
-          <a:prstGeom prst="rect">
-            <a:avLst/>
-          </a:prstGeom>
-          <a:noFill/>
-        </p:spPr>
-        <p:txBody>
-          <a:bodyPr wrap="square" lIns="0" rIns="0" tIns="0" bIns="0" anchor="ctr">
-            <a:spAutoFit/>
-          </a:bodyPr>
-          <a:lstStyle/>
-          <a:p>
-            <a:pPr algn="l"/>
-            <a:r>
-              <a:rPr sz="1100" b="1">
-                <a:solidFill>
-                  <a:srgbClr val="1F2A37"/>
-                </a:solidFill>
-                <a:latin typeface="Arial"/>
-              </a:rPr>
-              <a:t>Gobierno Corporativo</a:t>
-            </a:r>
-          </a:p>
-        </p:txBody>
-      </p:sp>
-      <p:sp>
-        <p:nvSpPr>
-          <p:cNvPr id="67" name="TextBox 66"/>
-          <p:cNvSpPr txBox="1"/>
-          <p:nvPr/>
-        </p:nvSpPr>
-        <p:spPr>
-          <a:xfrm>
-            <a:off x="9006840" y="5925312"/>
-            <a:ext cx="731520" cy="310896"/>
-          </a:xfrm>
-          <a:prstGeom prst="rect">
-            <a:avLst/>
-          </a:prstGeom>
-          <a:noFill/>
-        </p:spPr>
-        <p:txBody>
-          <a:bodyPr wrap="square" lIns="0" rIns="0" tIns="0" bIns="0" anchor="ctr">
-            <a:spAutoFit/>
-          </a:bodyPr>
-          <a:lstStyle/>
-          <a:p>
-            <a:pPr algn="l"/>
-            <a:r>
-              <a:rPr sz="1000" b="0">
-                <a:solidFill>
-                  <a:srgbClr val="5B6B7B"/>
-                </a:solidFill>
-                <a:latin typeface="Arial"/>
-              </a:rPr>
-              <a:t>NRP-17</a:t>
-            </a:r>
-          </a:p>
-        </p:txBody>
-      </p:sp>
-      <p:sp>
-        <p:nvSpPr>
-          <p:cNvPr id="68" name="Rounded Rectangle 67"/>
-          <p:cNvSpPr/>
-          <p:nvPr/>
-        </p:nvSpPr>
-        <p:spPr>
-          <a:xfrm>
-            <a:off x="9738359" y="5961888"/>
-            <a:ext cx="566928" cy="237744"/>
-          </a:xfrm>
-          <a:prstGeom prst="roundRect">
-            <a:avLst>
-              <a:gd name="adj" fmla="val 50000"/>
-            </a:avLst>
-          </a:prstGeom>
-          <a:solidFill>
-            <a:srgbClr val="1565C0"/>
-          </a:solidFill>
-          <a:ln>
-            <a:noFill/>
-          </a:ln>
-          <a:effectLst/>
-        </p:spPr>
-        <p:style>
-          <a:lnRef idx="1">
-            <a:schemeClr val="accent1"/>
-          </a:lnRef>
-          <a:fillRef idx="3">
-            <a:schemeClr val="accent1"/>
-          </a:fillRef>
-          <a:effectRef idx="2">
-            <a:schemeClr val="accent1"/>
-          </a:effectRef>
-          <a:fontRef idx="minor">
-            <a:schemeClr val="lt1"/>
-          </a:fontRef>
-        </p:style>
-        <p:txBody>
-          <a:bodyPr rtlCol="0" anchor="ctr" lIns="0" rIns="0" tIns="0" bIns="0"/>
-          <a:lstStyle/>
-          <a:p>
-            <a:pPr algn="ctr"/>
-            <a:r>
-              <a:rPr sz="900" b="1">
-                <a:solidFill>
-                  <a:srgbClr val="FFFFFF"/>
-                </a:solidFill>
-                <a:latin typeface="Arial"/>
-              </a:rPr>
-              <a:t>Interna</a:t>
-            </a:r>
-          </a:p>
-        </p:txBody>
-      </p:sp>
-      <p:sp>
-        <p:nvSpPr>
-          <p:cNvPr id="69" name="Rounded Rectangle 68"/>
-          <p:cNvSpPr/>
-          <p:nvPr/>
-        </p:nvSpPr>
-        <p:spPr>
-          <a:xfrm>
-            <a:off x="10378439" y="5961888"/>
-            <a:ext cx="566928" cy="237744"/>
-          </a:xfrm>
-          <a:prstGeom prst="roundRect">
-            <a:avLst>
-              <a:gd name="adj" fmla="val 50000"/>
-            </a:avLst>
-          </a:prstGeom>
-          <a:solidFill>
-            <a:srgbClr val="2E9E5B"/>
-          </a:solidFill>
-          <a:ln>
-            <a:noFill/>
-          </a:ln>
-          <a:effectLst/>
-        </p:spPr>
-        <p:style>
-          <a:lnRef idx="1">
-            <a:schemeClr val="accent1"/>
-          </a:lnRef>
-          <a:fillRef idx="3">
-            <a:schemeClr val="accent1"/>
-          </a:fillRef>
-          <a:effectRef idx="2">
-            <a:schemeClr val="accent1"/>
-          </a:effectRef>
-          <a:fontRef idx="minor">
-            <a:schemeClr val="lt1"/>
-          </a:fontRef>
-        </p:style>
-        <p:txBody>
-          <a:bodyPr rtlCol="0" anchor="ctr" lIns="0" rIns="0" tIns="0" bIns="0"/>
-          <a:lstStyle/>
-          <a:p>
-            <a:pPr algn="ctr"/>
-            <a:r>
-              <a:rPr sz="900" b="1">
-                <a:solidFill>
-                  <a:srgbClr val="FFFFFF"/>
-                </a:solidFill>
-                <a:latin typeface="Arial"/>
-              </a:rPr>
               <a:t>SSF</a:t>
             </a:r>
           </a:p>
@@ -6991,7 +6597,7 @@
       </p:sp>
       <p:sp>
         <p:nvSpPr>
-          <p:cNvPr id="70" name="Fuente"/>
+          <p:cNvPr id="61" name="Fuente"/>
           <p:cNvSpPr txBox="1"/>
           <p:nvPr/>
         </p:nvSpPr>

</xml_diff>

<commit_message>
Make all three summary options show the same verified figures
Recomputed every figure from the Consolidado sheet. Option B now shows
the most-audited norm (NRP-20) and distinct topic/norm counts per entity
instead of summed repetitions; all options show 19 visits, 26 distinct
topics, 4 repeated topics, NRP-20 and the October overlap.

Co-Authored-By: Claude Opus 5.5 <noreply@anthropic.com>
Claude-Session: https://claude.ai/code/session_01QC1XfLyMdcgUULyFVZxtv6
</commit_message>
<xml_diff>
--- a/presentacion-lunes/Resumen_Riesgos_2026_Opcion_A.pptx
+++ b/presentacion-lunes/Resumen_Riesgos_2026_Opcion_A.pptx
@@ -1038,7 +1038,7 @@
           <a:lstStyle/>
           <a:p>
             <a:r>
-              <a:t>Resumen de lo que nos pidieron en 2026. Vinieron 19 veces: 7 auditorías internas, 4 externas y 8 visitas de la SSF. Cuatro temas los pidieron 2 o más entidades: hay que tenerlos siempre listos, sobre todo las Actas del Comité de Riesgos (NRP-20), pedidas 4 veces; NCB-022 (cartera, Pérdida Esperada y remisiones a SSF) y el Plan de Continuidad, 3 veces cada uno. NRP-20 es la norma más revisada (5 veces, 3 entidades). En octubre coincidieron Interna, Externa y SSF.</a:t>
+              <a:t>Resumen de lo que nos pidieron en 2026. Vinieron 19 veces: 7 auditorías internas, 4 externas y 8 visitas de la SSF, y en total pidieron 26 temas distintos. Cuatro temas los pidieron 2 o más entidades: hay que tenerlos siempre listos. Las Actas del Comité de Riesgos (NRP-20) se pidieron 4 veces; los temas de NCB-022 (cartera y reservas, Pérdida Esperada, remisiones a SSF y matriz de migración) y el Plan de Continuidad, 3 veces cada uno; Gobierno Corporativo, 2 veces. NRP-20 es la norma más revisada: 5 veces, por 3 entidades. En octubre coincidieron Interna, Externa y SSF.</a:t>
             </a:r>
           </a:p>
         </p:txBody>
@@ -4741,7 +4741,7 @@
       </p:sp>
       <p:sp>
         <p:nvSpPr>
-          <p:cNvPr id="15" name="KPI temas solicitados"/>
+          <p:cNvPr id="15" name="KPI temas pedidos"/>
           <p:cNvSpPr/>
           <p:nvPr/>
         </p:nvSpPr>
@@ -4918,7 +4918,7 @@
                 </a:solidFill>
                 <a:latin typeface="Arial"/>
               </a:rPr>
-              <a:t>temas solicitados</a:t>
+              <a:t>temas pedidos</a:t>
             </a:r>
           </a:p>
         </p:txBody>
@@ -4953,7 +4953,7 @@
                 </a:solidFill>
                 <a:latin typeface="Arial"/>
               </a:rPr>
-              <a:t>de 31 temas del catálogo</a:t>
+              <a:t>distintos, de 31 del catálogo</a:t>
             </a:r>
           </a:p>
         </p:txBody>
@@ -6039,7 +6039,7 @@
                 </a:solidFill>
                 <a:latin typeface="Arial"/>
               </a:rPr>
-              <a:t>Cartera, mora y reservas · Pérdida Esperada · Remisiones a SSF</a:t>
+              <a:t>Cartera y reservas · Pérdida Esperada · Remisiones a SSF · Matriz de migración</a:t>
             </a:r>
           </a:p>
         </p:txBody>
@@ -6625,7 +6625,7 @@
                 </a:solidFill>
                 <a:latin typeface="Arial"/>
               </a:rPr>
-              <a:t>Fuente: Matriz de Requerimientos de Riesgos 2026, hoja «Resumen Riesgos» · corte octubre 2026</a:t>
+              <a:t>Fuente: Matriz de Requerimientos de Riesgos 2026, hojas «Resumen Riesgos» y «Consolidado» · corte octubre 2026</a:t>
             </a:r>
           </a:p>
         </p:txBody>

</xml_diff>

<commit_message>
Count repeated items by norm so every figure agrees across options
Topic-based (Actas = 4) and norm-based (NRP-20 = 5) counts were shown
side by side and contradicted each other. All three options now count
by norm: 5 norms reviewed by 2+ entities, NRP-20 = 5 everywhere.

Co-Authored-By: Claude Opus 5.5 <noreply@anthropic.com>
Claude-Session: https://claude.ai/code/session_01QC1XfLyMdcgUULyFVZxtv6
</commit_message>
<xml_diff>
--- a/presentacion-lunes/Resumen_Riesgos_2026_Opcion_A.pptx
+++ b/presentacion-lunes/Resumen_Riesgos_2026_Opcion_A.pptx
@@ -1038,7 +1038,7 @@
           <a:lstStyle/>
           <a:p>
             <a:r>
-              <a:t>Resumen de lo que nos pidieron en 2026. Vinieron 19 veces: 7 auditorías internas, 4 externas y 8 visitas de la SSF, y en total pidieron 26 temas distintos. Cuatro temas los pidieron 2 o más entidades: hay que tenerlos siempre listos. Las Actas del Comité de Riesgos (NRP-20) se pidieron 4 veces; los temas de NCB-022 (cartera y reservas, Pérdida Esperada, remisiones a SSF y matriz de migración) y el Plan de Continuidad, 3 veces cada uno; Gobierno Corporativo, 2 veces. NRP-20 es la norma más revisada: 5 veces, por 3 entidades. En octubre coincidieron Interna, Externa y SSF.</a:t>
+              <a:t>Resumen de lo que nos pidieron en 2026. Vinieron 19 veces: 7 auditorías internas, 4 externas y 8 visitas de la SSF, y pidieron 26 temas distintos. Contamos por norma: cada visita cuenta una vez por norma. Cinco normas las revisaron 2 o más entidades y hay que tenerlas siempre listas: NRP-20, 5 veces (Interna 2, Externa 1, SSF 2); NCB-022, 3 veces; NRP-24, 3 veces; NPB4-49, 2 veces; NRP-17, 2 veces. NRP-20 es la norma más revisada. En octubre coincidieron Interna, Externa y SSF.</a:t>
             </a:r>
           </a:p>
         </p:txBody>
@@ -4960,7 +4960,7 @@
       </p:sp>
       <p:sp>
         <p:nvSpPr>
-          <p:cNvPr id="21" name="KPI temas que se repiten"/>
+          <p:cNvPr id="21" name="KPI normas que se repiten"/>
           <p:cNvSpPr/>
           <p:nvPr/>
         </p:nvSpPr>
@@ -5102,7 +5102,7 @@
                 </a:solidFill>
                 <a:latin typeface="Century Gothic"/>
               </a:rPr>
-              <a:t>4</a:t>
+              <a:t>5</a:t>
             </a:r>
           </a:p>
         </p:txBody>
@@ -5137,7 +5137,7 @@
                 </a:solidFill>
                 <a:latin typeface="Arial"/>
               </a:rPr>
-              <a:t>temas que se repiten</a:t>
+              <a:t>normas que se repiten</a:t>
             </a:r>
           </a:p>
         </p:txBody>
@@ -5172,7 +5172,7 @@
                 </a:solidFill>
                 <a:latin typeface="Arial"/>
               </a:rPr>
-              <a:t>pedidos por 2 o más entidades</a:t>
+              <a:t>las revisan 2 o más entidades</a:t>
             </a:r>
           </a:p>
         </p:txBody>
@@ -5766,7 +5766,7 @@
                 </a:solidFill>
                 <a:latin typeface="Century Gothic"/>
               </a:rPr>
-              <a:t>Temas que se repiten: tenerlos siempre listos</a:t>
+              <a:t>Normas que se repiten: tenerlas siempre listas</a:t>
             </a:r>
           </a:p>
         </p:txBody>
@@ -5779,8 +5779,8 @@
         </p:nvSpPr>
         <p:spPr>
           <a:xfrm>
-            <a:off x="5943600" y="4005072"/>
-            <a:ext cx="5577840" cy="548640"/>
+            <a:off x="5943600" y="3977639"/>
+            <a:ext cx="5577840" cy="457200"/>
           </a:xfrm>
           <a:prstGeom prst="roundRect">
             <a:avLst>
@@ -5825,8 +5825,8 @@
         </p:nvSpPr>
         <p:spPr>
           <a:xfrm>
-            <a:off x="6080759" y="4041648"/>
-            <a:ext cx="2880360" cy="475488"/>
+            <a:off x="6080759" y="4005072"/>
+            <a:ext cx="3291840" cy="402336"/>
           </a:xfrm>
           <a:prstGeom prst="rect">
             <a:avLst/>
@@ -5841,42 +5841,7 @@
           <a:p>
             <a:pPr algn="l"/>
             <a:r>
-              <a:rPr sz="1100" b="1">
-                <a:solidFill>
-                  <a:srgbClr val="1F2A37"/>
-                </a:solidFill>
-                <a:latin typeface="Arial"/>
-              </a:rPr>
-              <a:t>Actas Comité de Riesgos</a:t>
-            </a:r>
-          </a:p>
-        </p:txBody>
-      </p:sp>
-      <p:sp>
-        <p:nvSpPr>
-          <p:cNvPr id="45" name="TextBox 44"/>
-          <p:cNvSpPr txBox="1"/>
-          <p:nvPr/>
-        </p:nvSpPr>
-        <p:spPr>
-          <a:xfrm>
-            <a:off x="9006840" y="4005072"/>
-            <a:ext cx="731520" cy="548640"/>
-          </a:xfrm>
-          <a:prstGeom prst="rect">
-            <a:avLst/>
-          </a:prstGeom>
-          <a:noFill/>
-        </p:spPr>
-        <p:txBody>
-          <a:bodyPr wrap="square" lIns="0" rIns="0" tIns="0" bIns="0" anchor="ctr">
-            <a:spAutoFit/>
-          </a:bodyPr>
-          <a:lstStyle/>
-          <a:p>
-            <a:pPr algn="l"/>
-            <a:r>
-              <a:rPr sz="1000" b="1">
+              <a:rPr sz="1200" b="1">
                 <a:solidFill>
                   <a:srgbClr val="003D6F"/>
                 </a:solidFill>
@@ -5884,19 +5849,40 @@
               </a:rPr>
               <a:t>NRP-20</a:t>
             </a:r>
-          </a:p>
-        </p:txBody>
-      </p:sp>
-      <p:sp>
-        <p:nvSpPr>
-          <p:cNvPr id="46" name="Rounded Rectangle 45"/>
+            <a:r>
+              <a:rPr sz="1000" b="1">
+                <a:solidFill>
+                  <a:srgbClr val="C62828"/>
+                </a:solidFill>
+                <a:latin typeface="Arial"/>
+              </a:rPr>
+              <a:t>   5 veces</a:t>
+            </a:r>
+          </a:p>
+          <a:p>
+            <a:pPr algn="l"/>
+            <a:r>
+              <a:rPr sz="900" b="0">
+                <a:solidFill>
+                  <a:srgbClr val="5B6B7B"/>
+                </a:solidFill>
+                <a:latin typeface="Arial"/>
+              </a:rPr>
+              <a:t>Actas · Informes GIR · Plan de trabajo · Visita integral SSF</a:t>
+            </a:r>
+          </a:p>
+        </p:txBody>
+      </p:sp>
+      <p:sp>
+        <p:nvSpPr>
+          <p:cNvPr id="45" name="Rounded Rectangle 44"/>
           <p:cNvSpPr/>
           <p:nvPr/>
         </p:nvSpPr>
         <p:spPr>
           <a:xfrm>
-            <a:off x="9738359" y="4160520"/>
-            <a:ext cx="731520" cy="237744"/>
+            <a:off x="9418320" y="4087368"/>
+            <a:ext cx="685800" cy="237744"/>
           </a:xfrm>
           <a:prstGeom prst="roundRect">
             <a:avLst>
@@ -5937,21 +5923,21 @@
                 </a:solidFill>
                 <a:latin typeface="Arial"/>
               </a:rPr>
-              <a:t>Interna ×3</a:t>
-            </a:r>
-          </a:p>
-        </p:txBody>
-      </p:sp>
-      <p:sp>
-        <p:nvSpPr>
-          <p:cNvPr id="47" name="Rounded Rectangle 46"/>
+              <a:t>Interna ×2</a:t>
+            </a:r>
+          </a:p>
+        </p:txBody>
+      </p:sp>
+      <p:sp>
+        <p:nvSpPr>
+          <p:cNvPr id="46" name="Rounded Rectangle 45"/>
           <p:cNvSpPr/>
           <p:nvPr/>
         </p:nvSpPr>
         <p:spPr>
           <a:xfrm>
-            <a:off x="10543032" y="4160520"/>
-            <a:ext cx="566928" cy="237744"/>
+            <a:off x="10177272" y="4087368"/>
+            <a:ext cx="530352" cy="237744"/>
           </a:xfrm>
           <a:prstGeom prst="roundRect">
             <a:avLst>
@@ -5999,14 +5985,69 @@
       </p:sp>
       <p:sp>
         <p:nvSpPr>
+          <p:cNvPr id="47" name="Rounded Rectangle 46"/>
+          <p:cNvSpPr/>
+          <p:nvPr/>
+        </p:nvSpPr>
+        <p:spPr>
+          <a:xfrm>
+            <a:off x="10780776" y="4087368"/>
+            <a:ext cx="685800" cy="237744"/>
+          </a:xfrm>
+          <a:prstGeom prst="roundRect">
+            <a:avLst>
+              <a:gd name="adj" fmla="val 50000"/>
+            </a:avLst>
+          </a:prstGeom>
+          <a:solidFill>
+            <a:srgbClr val="2E9E5B"/>
+          </a:solidFill>
+          <a:ln>
+            <a:noFill/>
+          </a:ln>
+          <a:effectLst/>
+        </p:spPr>
+        <p:style>
+          <a:lnRef idx="1">
+            <a:schemeClr val="accent1"/>
+          </a:lnRef>
+          <a:fillRef idx="3">
+            <a:schemeClr val="accent1"/>
+          </a:fillRef>
+          <a:effectRef idx="2">
+            <a:schemeClr val="accent1"/>
+          </a:effectRef>
+          <a:fontRef idx="minor">
+            <a:schemeClr val="lt1"/>
+          </a:fontRef>
+        </p:style>
+        <p:txBody>
+          <a:bodyPr rtlCol="0" anchor="ctr" lIns="0" rIns="0" tIns="0" bIns="0"/>
+          <a:lstStyle/>
+          <a:p>
+            <a:pPr algn="ctr"/>
+            <a:r>
+              <a:rPr sz="900" b="1">
+                <a:solidFill>
+                  <a:srgbClr val="FFFFFF"/>
+                </a:solidFill>
+                <a:latin typeface="Arial"/>
+              </a:rPr>
+              <a:t>SSF ×2</a:t>
+            </a:r>
+          </a:p>
+        </p:txBody>
+      </p:sp>
+      <p:sp>
+        <p:nvSpPr>
           <p:cNvPr id="48" name="TextBox 47"/>
           <p:cNvSpPr txBox="1"/>
           <p:nvPr/>
         </p:nvSpPr>
         <p:spPr>
           <a:xfrm>
-            <a:off x="6080759" y="4608576"/>
-            <a:ext cx="2880360" cy="475488"/>
+            <a:off x="6080759" y="4462272"/>
+            <a:ext cx="3291840" cy="402336"/>
           </a:xfrm>
           <a:prstGeom prst="rect">
             <a:avLst/>
@@ -6021,13 +6062,22 @@
           <a:p>
             <a:pPr algn="l"/>
             <a:r>
-              <a:rPr sz="1100" b="1">
+              <a:rPr sz="1200" b="1">
                 <a:solidFill>
-                  <a:srgbClr val="1F2A37"/>
+                  <a:srgbClr val="003D6F"/>
                 </a:solidFill>
                 <a:latin typeface="Arial"/>
               </a:rPr>
-              <a:t>Riesgo de crédito</a:t>
+              <a:t>NCB-022</a:t>
+            </a:r>
+            <a:r>
+              <a:rPr sz="1000" b="1">
+                <a:solidFill>
+                  <a:srgbClr val="C62828"/>
+                </a:solidFill>
+                <a:latin typeface="Arial"/>
+              </a:rPr>
+              <a:t>   3 veces</a:t>
             </a:r>
           </a:p>
           <a:p>
@@ -6039,56 +6089,21 @@
                 </a:solidFill>
                 <a:latin typeface="Arial"/>
               </a:rPr>
-              <a:t>Cartera y reservas · Pérdida Esperada · Remisiones a SSF · Matriz de migración</a:t>
-            </a:r>
-          </a:p>
-        </p:txBody>
-      </p:sp>
-      <p:sp>
-        <p:nvSpPr>
-          <p:cNvPr id="49" name="TextBox 48"/>
-          <p:cNvSpPr txBox="1"/>
-          <p:nvPr/>
-        </p:nvSpPr>
-        <p:spPr>
-          <a:xfrm>
-            <a:off x="9006840" y="4572000"/>
-            <a:ext cx="731520" cy="548640"/>
-          </a:xfrm>
-          <a:prstGeom prst="rect">
-            <a:avLst/>
-          </a:prstGeom>
-          <a:noFill/>
-        </p:spPr>
-        <p:txBody>
-          <a:bodyPr wrap="square" lIns="0" rIns="0" tIns="0" bIns="0" anchor="ctr">
-            <a:spAutoFit/>
-          </a:bodyPr>
-          <a:lstStyle/>
-          <a:p>
-            <a:pPr algn="l"/>
-            <a:r>
-              <a:rPr sz="1000" b="1">
-                <a:solidFill>
-                  <a:srgbClr val="003D6F"/>
-                </a:solidFill>
-                <a:latin typeface="Arial"/>
-              </a:rPr>
-              <a:t>NCB-022</a:t>
-            </a:r>
-          </a:p>
-        </p:txBody>
-      </p:sp>
-      <p:sp>
-        <p:nvSpPr>
-          <p:cNvPr id="50" name="Rounded Rectangle 49"/>
+              <a:t>Cartera · Pérdida Esperada · Remisiones SSF · Migración</a:t>
+            </a:r>
+          </a:p>
+        </p:txBody>
+      </p:sp>
+      <p:sp>
+        <p:nvSpPr>
+          <p:cNvPr id="49" name="Rounded Rectangle 48"/>
           <p:cNvSpPr/>
           <p:nvPr/>
         </p:nvSpPr>
         <p:spPr>
           <a:xfrm>
-            <a:off x="9738359" y="4727448"/>
-            <a:ext cx="731520" cy="237744"/>
+            <a:off x="9418320" y="4544568"/>
+            <a:ext cx="685800" cy="237744"/>
           </a:xfrm>
           <a:prstGeom prst="roundRect">
             <a:avLst>
@@ -6136,14 +6151,14 @@
       </p:sp>
       <p:sp>
         <p:nvSpPr>
-          <p:cNvPr id="51" name="Rounded Rectangle 50"/>
+          <p:cNvPr id="50" name="Rounded Rectangle 49"/>
           <p:cNvSpPr/>
           <p:nvPr/>
         </p:nvSpPr>
         <p:spPr>
           <a:xfrm>
-            <a:off x="10543032" y="4727448"/>
-            <a:ext cx="566928" cy="237744"/>
+            <a:off x="10177272" y="4544568"/>
+            <a:ext cx="530352" cy="237744"/>
           </a:xfrm>
           <a:prstGeom prst="roundRect">
             <a:avLst>
@@ -6191,14 +6206,14 @@
       </p:sp>
       <p:sp>
         <p:nvSpPr>
-          <p:cNvPr id="52" name="Rounded Rectangle 51"/>
+          <p:cNvPr id="51" name="Rounded Rectangle 50"/>
           <p:cNvSpPr/>
           <p:nvPr/>
         </p:nvSpPr>
         <p:spPr>
           <a:xfrm>
-            <a:off x="5943600" y="5138928"/>
-            <a:ext cx="5577840" cy="548640"/>
+            <a:off x="5943600" y="4892040"/>
+            <a:ext cx="5577840" cy="457200"/>
           </a:xfrm>
           <a:prstGeom prst="roundRect">
             <a:avLst>
@@ -6237,14 +6252,14 @@
       </p:sp>
       <p:sp>
         <p:nvSpPr>
-          <p:cNvPr id="53" name="TextBox 52"/>
+          <p:cNvPr id="52" name="TextBox 51"/>
           <p:cNvSpPr txBox="1"/>
           <p:nvPr/>
         </p:nvSpPr>
         <p:spPr>
           <a:xfrm>
-            <a:off x="6080759" y="5175504"/>
-            <a:ext cx="2880360" cy="475488"/>
+            <a:off x="6080759" y="4919472"/>
+            <a:ext cx="3291840" cy="402336"/>
           </a:xfrm>
           <a:prstGeom prst="rect">
             <a:avLst/>
@@ -6259,42 +6274,7 @@
           <a:p>
             <a:pPr algn="l"/>
             <a:r>
-              <a:rPr sz="1100" b="1">
-                <a:solidFill>
-                  <a:srgbClr val="1F2A37"/>
-                </a:solidFill>
-                <a:latin typeface="Arial"/>
-              </a:rPr>
-              <a:t>Plan de Continuidad (BCP/DRP)</a:t>
-            </a:r>
-          </a:p>
-        </p:txBody>
-      </p:sp>
-      <p:sp>
-        <p:nvSpPr>
-          <p:cNvPr id="54" name="TextBox 53"/>
-          <p:cNvSpPr txBox="1"/>
-          <p:nvPr/>
-        </p:nvSpPr>
-        <p:spPr>
-          <a:xfrm>
-            <a:off x="9006840" y="5138928"/>
-            <a:ext cx="731520" cy="548640"/>
-          </a:xfrm>
-          <a:prstGeom prst="rect">
-            <a:avLst/>
-          </a:prstGeom>
-          <a:noFill/>
-        </p:spPr>
-        <p:txBody>
-          <a:bodyPr wrap="square" lIns="0" rIns="0" tIns="0" bIns="0" anchor="ctr">
-            <a:spAutoFit/>
-          </a:bodyPr>
-          <a:lstStyle/>
-          <a:p>
-            <a:pPr algn="l"/>
-            <a:r>
-              <a:rPr sz="1000" b="1">
+              <a:rPr sz="1200" b="1">
                 <a:solidFill>
                   <a:srgbClr val="003D6F"/>
                 </a:solidFill>
@@ -6302,19 +6282,40 @@
               </a:rPr>
               <a:t>NRP-24</a:t>
             </a:r>
-          </a:p>
-        </p:txBody>
-      </p:sp>
-      <p:sp>
-        <p:nvSpPr>
-          <p:cNvPr id="55" name="Rounded Rectangle 54"/>
+            <a:r>
+              <a:rPr sz="1000" b="1">
+                <a:solidFill>
+                  <a:srgbClr val="C62828"/>
+                </a:solidFill>
+                <a:latin typeface="Arial"/>
+              </a:rPr>
+              <a:t>   3 veces</a:t>
+            </a:r>
+          </a:p>
+          <a:p>
+            <a:pPr algn="l"/>
+            <a:r>
+              <a:rPr sz="900" b="0">
+                <a:solidFill>
+                  <a:srgbClr val="5B6B7B"/>
+                </a:solidFill>
+                <a:latin typeface="Arial"/>
+              </a:rPr>
+              <a:t>Plan de Continuidad (BCP/DRP) · Actas del 16 de octubre</a:t>
+            </a:r>
+          </a:p>
+        </p:txBody>
+      </p:sp>
+      <p:sp>
+        <p:nvSpPr>
+          <p:cNvPr id="53" name="Rounded Rectangle 52"/>
           <p:cNvSpPr/>
           <p:nvPr/>
         </p:nvSpPr>
         <p:spPr>
           <a:xfrm>
-            <a:off x="9738359" y="5294376"/>
-            <a:ext cx="731520" cy="237744"/>
+            <a:off x="9418320" y="5001768"/>
+            <a:ext cx="685800" cy="237744"/>
           </a:xfrm>
           <a:prstGeom prst="roundRect">
             <a:avLst>
@@ -6362,14 +6363,14 @@
       </p:sp>
       <p:sp>
         <p:nvSpPr>
-          <p:cNvPr id="56" name="Rounded Rectangle 55"/>
+          <p:cNvPr id="54" name="Rounded Rectangle 53"/>
           <p:cNvSpPr/>
           <p:nvPr/>
         </p:nvSpPr>
         <p:spPr>
           <a:xfrm>
-            <a:off x="10543032" y="5294376"/>
-            <a:ext cx="566928" cy="237744"/>
+            <a:off x="10177272" y="5001768"/>
+            <a:ext cx="530352" cy="237744"/>
           </a:xfrm>
           <a:prstGeom prst="roundRect">
             <a:avLst>
@@ -6417,14 +6418,14 @@
       </p:sp>
       <p:sp>
         <p:nvSpPr>
-          <p:cNvPr id="57" name="TextBox 56"/>
+          <p:cNvPr id="55" name="TextBox 54"/>
           <p:cNvSpPr txBox="1"/>
           <p:nvPr/>
         </p:nvSpPr>
         <p:spPr>
           <a:xfrm>
-            <a:off x="6080759" y="5742432"/>
-            <a:ext cx="2880360" cy="475488"/>
+            <a:off x="6080759" y="5376672"/>
+            <a:ext cx="3291840" cy="402336"/>
           </a:xfrm>
           <a:prstGeom prst="rect">
             <a:avLst/>
@@ -6439,62 +6440,48 @@
           <a:p>
             <a:pPr algn="l"/>
             <a:r>
-              <a:rPr sz="1100" b="1">
-                <a:solidFill>
-                  <a:srgbClr val="1F2A37"/>
-                </a:solidFill>
-                <a:latin typeface="Arial"/>
-              </a:rPr>
-              <a:t>Gobierno Corporativo</a:t>
-            </a:r>
-          </a:p>
-        </p:txBody>
-      </p:sp>
-      <p:sp>
-        <p:nvSpPr>
-          <p:cNvPr id="58" name="TextBox 57"/>
-          <p:cNvSpPr txBox="1"/>
-          <p:nvPr/>
-        </p:nvSpPr>
-        <p:spPr>
-          <a:xfrm>
-            <a:off x="9006840" y="5705856"/>
-            <a:ext cx="731520" cy="548640"/>
-          </a:xfrm>
-          <a:prstGeom prst="rect">
-            <a:avLst/>
-          </a:prstGeom>
-          <a:noFill/>
-        </p:spPr>
-        <p:txBody>
-          <a:bodyPr wrap="square" lIns="0" rIns="0" tIns="0" bIns="0" anchor="ctr">
-            <a:spAutoFit/>
-          </a:bodyPr>
-          <a:lstStyle/>
-          <a:p>
-            <a:pPr algn="l"/>
-            <a:r>
-              <a:rPr sz="1000" b="1">
+              <a:rPr sz="1200" b="1">
                 <a:solidFill>
                   <a:srgbClr val="003D6F"/>
                 </a:solidFill>
                 <a:latin typeface="Arial"/>
               </a:rPr>
-              <a:t>NRP-17</a:t>
-            </a:r>
-          </a:p>
-        </p:txBody>
-      </p:sp>
-      <p:sp>
-        <p:nvSpPr>
-          <p:cNvPr id="59" name="Rounded Rectangle 58"/>
+              <a:t>NPB4-49</a:t>
+            </a:r>
+            <a:r>
+              <a:rPr sz="1000" b="1">
+                <a:solidFill>
+                  <a:srgbClr val="5B6B7B"/>
+                </a:solidFill>
+                <a:latin typeface="Arial"/>
+              </a:rPr>
+              <a:t>   2 veces</a:t>
+            </a:r>
+          </a:p>
+          <a:p>
+            <a:pPr algn="l"/>
+            <a:r>
+              <a:rPr sz="900" b="0">
+                <a:solidFill>
+                  <a:srgbClr val="5B6B7B"/>
+                </a:solidFill>
+                <a:latin typeface="Arial"/>
+              </a:rPr>
+              <a:t>Escenarios de estrés · Concentración crediticia</a:t>
+            </a:r>
+          </a:p>
+        </p:txBody>
+      </p:sp>
+      <p:sp>
+        <p:nvSpPr>
+          <p:cNvPr id="56" name="Rounded Rectangle 55"/>
           <p:cNvSpPr/>
           <p:nvPr/>
         </p:nvSpPr>
         <p:spPr>
           <a:xfrm>
-            <a:off x="9738359" y="5861304"/>
-            <a:ext cx="566928" cy="237744"/>
+            <a:off x="9418320" y="5458968"/>
+            <a:ext cx="530352" cy="237744"/>
           </a:xfrm>
           <a:prstGeom prst="roundRect">
             <a:avLst>
@@ -6542,14 +6529,226 @@
       </p:sp>
       <p:sp>
         <p:nvSpPr>
+          <p:cNvPr id="57" name="Rounded Rectangle 56"/>
+          <p:cNvSpPr/>
+          <p:nvPr/>
+        </p:nvSpPr>
+        <p:spPr>
+          <a:xfrm>
+            <a:off x="10021824" y="5458968"/>
+            <a:ext cx="530352" cy="237744"/>
+          </a:xfrm>
+          <a:prstGeom prst="roundRect">
+            <a:avLst>
+              <a:gd name="adj" fmla="val 50000"/>
+            </a:avLst>
+          </a:prstGeom>
+          <a:solidFill>
+            <a:srgbClr val="E8871E"/>
+          </a:solidFill>
+          <a:ln>
+            <a:noFill/>
+          </a:ln>
+          <a:effectLst/>
+        </p:spPr>
+        <p:style>
+          <a:lnRef idx="1">
+            <a:schemeClr val="accent1"/>
+          </a:lnRef>
+          <a:fillRef idx="3">
+            <a:schemeClr val="accent1"/>
+          </a:fillRef>
+          <a:effectRef idx="2">
+            <a:schemeClr val="accent1"/>
+          </a:effectRef>
+          <a:fontRef idx="minor">
+            <a:schemeClr val="lt1"/>
+          </a:fontRef>
+        </p:style>
+        <p:txBody>
+          <a:bodyPr rtlCol="0" anchor="ctr" lIns="0" rIns="0" tIns="0" bIns="0"/>
+          <a:lstStyle/>
+          <a:p>
+            <a:pPr algn="ctr"/>
+            <a:r>
+              <a:rPr sz="900" b="1">
+                <a:solidFill>
+                  <a:srgbClr val="FFFFFF"/>
+                </a:solidFill>
+                <a:latin typeface="Arial"/>
+              </a:rPr>
+              <a:t>Externa</a:t>
+            </a:r>
+          </a:p>
+        </p:txBody>
+      </p:sp>
+      <p:sp>
+        <p:nvSpPr>
+          <p:cNvPr id="58" name="Rounded Rectangle 57"/>
+          <p:cNvSpPr/>
+          <p:nvPr/>
+        </p:nvSpPr>
+        <p:spPr>
+          <a:xfrm>
+            <a:off x="5943600" y="5806440"/>
+            <a:ext cx="5577840" cy="457200"/>
+          </a:xfrm>
+          <a:prstGeom prst="roundRect">
+            <a:avLst>
+              <a:gd name="adj" fmla="val 15000"/>
+            </a:avLst>
+          </a:prstGeom>
+          <a:solidFill>
+            <a:srgbClr val="EEF3F9"/>
+          </a:solidFill>
+          <a:ln>
+            <a:noFill/>
+          </a:ln>
+          <a:effectLst/>
+        </p:spPr>
+        <p:style>
+          <a:lnRef idx="1">
+            <a:schemeClr val="accent1"/>
+          </a:lnRef>
+          <a:fillRef idx="3">
+            <a:schemeClr val="accent1"/>
+          </a:fillRef>
+          <a:effectRef idx="2">
+            <a:schemeClr val="accent1"/>
+          </a:effectRef>
+          <a:fontRef idx="minor">
+            <a:schemeClr val="lt1"/>
+          </a:fontRef>
+        </p:style>
+        <p:txBody>
+          <a:bodyPr rtlCol="0" anchor="ctr"/>
+          <a:lstStyle/>
+          <a:p>
+            <a:pPr algn="ctr"/>
+          </a:p>
+        </p:txBody>
+      </p:sp>
+      <p:sp>
+        <p:nvSpPr>
+          <p:cNvPr id="59" name="TextBox 58"/>
+          <p:cNvSpPr txBox="1"/>
+          <p:nvPr/>
+        </p:nvSpPr>
+        <p:spPr>
+          <a:xfrm>
+            <a:off x="6080759" y="5833872"/>
+            <a:ext cx="3291840" cy="402336"/>
+          </a:xfrm>
+          <a:prstGeom prst="rect">
+            <a:avLst/>
+          </a:prstGeom>
+          <a:noFill/>
+        </p:spPr>
+        <p:txBody>
+          <a:bodyPr wrap="square" lIns="0" rIns="0" tIns="0" bIns="0" anchor="ctr">
+            <a:spAutoFit/>
+          </a:bodyPr>
+          <a:lstStyle/>
+          <a:p>
+            <a:pPr algn="l"/>
+            <a:r>
+              <a:rPr sz="1200" b="1">
+                <a:solidFill>
+                  <a:srgbClr val="003D6F"/>
+                </a:solidFill>
+                <a:latin typeface="Arial"/>
+              </a:rPr>
+              <a:t>NRP-17</a:t>
+            </a:r>
+            <a:r>
+              <a:rPr sz="1000" b="1">
+                <a:solidFill>
+                  <a:srgbClr val="5B6B7B"/>
+                </a:solidFill>
+                <a:latin typeface="Arial"/>
+              </a:rPr>
+              <a:t>   2 veces</a:t>
+            </a:r>
+          </a:p>
+          <a:p>
+            <a:pPr algn="l"/>
+            <a:r>
+              <a:rPr sz="900" b="0">
+                <a:solidFill>
+                  <a:srgbClr val="5B6B7B"/>
+                </a:solidFill>
+                <a:latin typeface="Arial"/>
+              </a:rPr>
+              <a:t>Gobierno Corporativo</a:t>
+            </a:r>
+          </a:p>
+        </p:txBody>
+      </p:sp>
+      <p:sp>
+        <p:nvSpPr>
           <p:cNvPr id="60" name="Rounded Rectangle 59"/>
           <p:cNvSpPr/>
           <p:nvPr/>
         </p:nvSpPr>
         <p:spPr>
           <a:xfrm>
-            <a:off x="10378439" y="5861304"/>
-            <a:ext cx="566928" cy="237744"/>
+            <a:off x="9418320" y="5916168"/>
+            <a:ext cx="530352" cy="237744"/>
+          </a:xfrm>
+          <a:prstGeom prst="roundRect">
+            <a:avLst>
+              <a:gd name="adj" fmla="val 50000"/>
+            </a:avLst>
+          </a:prstGeom>
+          <a:solidFill>
+            <a:srgbClr val="1565C0"/>
+          </a:solidFill>
+          <a:ln>
+            <a:noFill/>
+          </a:ln>
+          <a:effectLst/>
+        </p:spPr>
+        <p:style>
+          <a:lnRef idx="1">
+            <a:schemeClr val="accent1"/>
+          </a:lnRef>
+          <a:fillRef idx="3">
+            <a:schemeClr val="accent1"/>
+          </a:fillRef>
+          <a:effectRef idx="2">
+            <a:schemeClr val="accent1"/>
+          </a:effectRef>
+          <a:fontRef idx="minor">
+            <a:schemeClr val="lt1"/>
+          </a:fontRef>
+        </p:style>
+        <p:txBody>
+          <a:bodyPr rtlCol="0" anchor="ctr" lIns="0" rIns="0" tIns="0" bIns="0"/>
+          <a:lstStyle/>
+          <a:p>
+            <a:pPr algn="ctr"/>
+            <a:r>
+              <a:rPr sz="900" b="1">
+                <a:solidFill>
+                  <a:srgbClr val="FFFFFF"/>
+                </a:solidFill>
+                <a:latin typeface="Arial"/>
+              </a:rPr>
+              <a:t>Interna</a:t>
+            </a:r>
+          </a:p>
+        </p:txBody>
+      </p:sp>
+      <p:sp>
+        <p:nvSpPr>
+          <p:cNvPr id="61" name="Rounded Rectangle 60"/>
+          <p:cNvSpPr/>
+          <p:nvPr/>
+        </p:nvSpPr>
+        <p:spPr>
+          <a:xfrm>
+            <a:off x="10021824" y="5916168"/>
+            <a:ext cx="530352" cy="237744"/>
           </a:xfrm>
           <a:prstGeom prst="roundRect">
             <a:avLst>
@@ -6597,7 +6796,7 @@
       </p:sp>
       <p:sp>
         <p:nvSpPr>
-          <p:cNvPr id="61" name="Fuente"/>
+          <p:cNvPr id="62" name="Fuente"/>
           <p:cNvSpPr txBox="1"/>
           <p:nvPr/>
         </p:nvSpPr>

</xml_diff>